<commit_message>
feat: adopt transparent PNG calligraphy emblem across HAKMDAR 0.2, web app, and PPTX presentation
</commit_message>
<xml_diff>
--- a/public/HAKMDAR_0.2_Graduation_Presentation.pptx
+++ b/public/HAKMDAR_0.2_Graduation_Presentation.pptx
@@ -3201,7 +3201,7 @@
         </p:blipFill>
         <p:spPr>
           <a:xfrm>
-            <a:off x="4998110" y="731520"/>
+            <a:off x="4998110" y="685800"/>
             <a:ext cx="2194560" cy="2194560"/>
           </a:xfrm>
           <a:prstGeom prst="rect">
@@ -3217,7 +3217,7 @@
         </p:nvSpPr>
         <p:spPr>
           <a:xfrm>
-            <a:off x="2286000" y="2971800"/>
+            <a:off x="2286000" y="2926080"/>
             <a:ext cx="7619695" cy="365760"/>
           </a:xfrm>
           <a:prstGeom prst="rect">
@@ -3252,7 +3252,7 @@
         </p:nvSpPr>
         <p:spPr>
           <a:xfrm>
-            <a:off x="1828800" y="3337560"/>
+            <a:off x="1828800" y="3291840"/>
             <a:ext cx="8534095" cy="777240"/>
           </a:xfrm>
           <a:prstGeom prst="rect">
@@ -3287,7 +3287,7 @@
         </p:nvSpPr>
         <p:spPr>
           <a:xfrm>
-            <a:off x="1828800" y="4114800"/>
+            <a:off x="1828800" y="4069080"/>
             <a:ext cx="8534095" cy="502920"/>
           </a:xfrm>
           <a:prstGeom prst="rect">
@@ -3322,7 +3322,7 @@
         </p:nvSpPr>
         <p:spPr>
           <a:xfrm>
-            <a:off x="2011680" y="4617720"/>
+            <a:off x="2011680" y="4572000"/>
             <a:ext cx="8168335" cy="594360"/>
           </a:xfrm>
           <a:prstGeom prst="rect">
@@ -3357,7 +3357,7 @@
         </p:nvSpPr>
         <p:spPr>
           <a:xfrm>
-            <a:off x="2286000" y="5440680"/>
+            <a:off x="2286000" y="5394960"/>
             <a:ext cx="7619695" cy="457200"/>
           </a:xfrm>
           <a:prstGeom prst="rect">
@@ -3506,7 +3506,7 @@
         </p:blipFill>
         <p:spPr>
           <a:xfrm>
-            <a:off x="4998110" y="731520"/>
+            <a:off x="4998110" y="685800"/>
             <a:ext cx="2194560" cy="2194560"/>
           </a:xfrm>
           <a:prstGeom prst="rect">

</xml_diff>